<commit_message>
Errata Corrected, new slide added, .pptx not formatted
</commit_message>
<xml_diff>
--- a/Course#10/MintClassics.pptx
+++ b/Course#10/MintClassics.pptx
@@ -21,6 +21,7 @@
     <p:sldId id="269" r:id="rId17"/>
     <p:sldId id="270" r:id="rId18"/>
     <p:sldId id="271" r:id="rId19"/>
+    <p:sldId id="272" r:id="rId20"/>
   </p:sldIdLst>
   <p:sldSz cx="10080625" cy="7559675"/>
   <p:notesSz cx="7559675" cy="10691813"/>
@@ -1063,7 +1064,7 @@
                   <a:srgbClr val="FFFFFF"/>
                 </a:solidFill>
               </a:rPr>
-              <a:t>Look into Warehouse Shipping Efficiency</a:t>
+              <a:t>Check the Warehouse Contents</a:t>
             </a:r>
           </a:p>
         </p:txBody>
@@ -1097,70 +1098,36 @@
                   <a:srgbClr val="FFFFFF"/>
                 </a:solidFill>
               </a:rPr>
-              <a:t>Orders shipped from multiple warehouses DO NOT differentiate their date of shipment from each warehouse individually, THEREFORE the aggregated totals for each will only show a difference if a given warehouse is performing differently than average.</a:t>
-            </a:r>
-          </a:p>
-        </p:txBody>
-      </p:sp>
-      <p:sp>
-        <p:nvSpPr>
-          <p:cNvPr id="6" name="TextBox 5"/>
-          <p:cNvSpPr txBox="1"/>
-          <p:nvPr/>
-        </p:nvSpPr>
-        <p:spPr>
-          <a:xfrm>
-            <a:off x="640080" y="2286000"/>
-            <a:ext cx="8778240" cy="4114800"/>
-          </a:xfrm>
-          <a:prstGeom prst="rect">
-            <a:avLst/>
-          </a:prstGeom>
-          <a:noFill/>
-        </p:spPr>
-        <p:txBody>
-          <a:bodyPr wrap="square">
-            <a:spAutoFit/>
-          </a:bodyPr>
-          <a:lstStyle/>
-          <a:p>
-            <a:pPr algn="l"/>
-            <a:r>
-              <a:rPr sz="2200">
-                <a:solidFill>
-                  <a:srgbClr val="FFFFFF"/>
-                </a:solidFill>
-              </a:rPr>
-              <a:t>- Check the amount of time each warehouse requires to ship an order.</a:t>
-            </a:r>
-          </a:p>
-          <a:p>
-            <a:pPr algn="l"/>
-            <a:r>
-              <a:rPr sz="2200">
-                <a:solidFill>
-                  <a:srgbClr val="FFFFFF"/>
-                </a:solidFill>
-              </a:rPr>
-              <a:t>- Look for shipping delays from each warehouse.</a:t>
-            </a:r>
-          </a:p>
-          <a:p>
-            <a:pPr algn="l"/>
-            <a:r>
-              <a:rPr sz="2200">
-                <a:solidFill>
-                  <a:srgbClr val="FFFFFF"/>
-                </a:solidFill>
-              </a:rPr>
-              <a:t>- Determine if shipping delays are incidental or a systemic issue.</a:t>
+              <a:t>- It can be seen that the large warehouse "B" contains only 'Classic Cars'.</a:t>
+            </a:r>
+          </a:p>
+          <a:p>
+            <a:pPr algn="l"/>
+            <a:r>
+              <a:rPr sz="2200">
+                <a:solidFill>
+                  <a:srgbClr val="FFFFFF"/>
+                </a:solidFill>
+              </a:rPr>
+              <a:t>- The warehouse which is a candidate for closure, "C", contains only 'Vintage Cars'.</a:t>
+            </a:r>
+          </a:p>
+          <a:p>
+            <a:pPr algn="l"/>
+            <a:r>
+              <a:rPr sz="2200">
+                <a:solidFill>
+                  <a:srgbClr val="FFFFFF"/>
+                </a:solidFill>
+              </a:rPr>
+              <a:t>- Merging the contents of warehouses B and C would allow for the full stock of 'Cars' to be housed in a single location.</a:t>
             </a:r>
           </a:p>
         </p:txBody>
       </p:sp>
       <p:pic>
         <p:nvPicPr>
-          <p:cNvPr id="7" name="Picture 6" descr="table_2.png"/>
+          <p:cNvPr id="6" name="Picture 5" descr="table_2.png"/>
           <p:cNvPicPr>
             <a:picLocks noChangeAspect="1"/>
           </p:cNvPicPr>
@@ -1175,31 +1142,7 @@
         <p:spPr>
           <a:xfrm>
             <a:off x="914400" y="914400"/>
-            <a:ext cx="6199632" cy="3561588"/>
-          </a:xfrm>
-          <a:prstGeom prst="rect">
-            <a:avLst/>
-          </a:prstGeom>
-        </p:spPr>
-      </p:pic>
-      <p:pic>
-        <p:nvPicPr>
-          <p:cNvPr id="8" name="Picture 7" descr="output_54_0.png"/>
-          <p:cNvPicPr>
-            <a:picLocks noChangeAspect="1"/>
-          </p:cNvPicPr>
-          <p:nvPr/>
-        </p:nvPicPr>
-        <p:blipFill>
-          <a:blip r:embed="rId3"/>
-          <a:stretch>
-            <a:fillRect/>
-          </a:stretch>
-        </p:blipFill>
-        <p:spPr>
-          <a:xfrm>
-            <a:off x="1371600" y="1371600"/>
-            <a:ext cx="10881360" cy="5394960"/>
+            <a:ext cx="6752844" cy="3561588"/>
           </a:xfrm>
           <a:prstGeom prst="rect">
             <a:avLst/>
@@ -1347,7 +1290,7 @@
                   <a:srgbClr val="FFFFFF"/>
                 </a:solidFill>
               </a:rPr>
-              <a:t>Warehouse Shipping Efficiency (cont'd)</a:t>
+              <a:t>Look into Warehouse Shipping Efficiency</a:t>
             </a:r>
           </a:p>
         </p:txBody>
@@ -1381,7 +1324,7 @@
                   <a:srgbClr val="FFFFFF"/>
                 </a:solidFill>
               </a:rPr>
-              <a:t>After splitting the shipping delays into occurrences by location, normalized to maximum orders per bin:</a:t>
+              <a:t>Orders shipped from multiple warehouses DO NOT differentiate their date of shipment from each warehouse individually, THEREFORE the aggregated totals for each will only show a difference if a given warehouse is performing differently than average.</a:t>
             </a:r>
           </a:p>
         </p:txBody>
@@ -1415,36 +1358,36 @@
                   <a:srgbClr val="FFFFFF"/>
                 </a:solidFill>
               </a:rPr>
-              <a:t>- Warehouse 'B' has proportionally more One-Day shipping delays than the other warehouses.</a:t>
-            </a:r>
-          </a:p>
-          <a:p>
-            <a:pPr algn="l"/>
-            <a:r>
-              <a:rPr sz="2200">
-                <a:solidFill>
-                  <a:srgbClr val="FFFFFF"/>
-                </a:solidFill>
-              </a:rPr>
-              <a:t>- If warehouse 'C' were to be moved into warehouse 'B' then warehouse 'B' must be able to accommodate an extra 100 orders worth of source/process/ship per day.</a:t>
-            </a:r>
-          </a:p>
-          <a:p>
-            <a:pPr algn="l"/>
-            <a:r>
-              <a:rPr sz="2200">
-                <a:solidFill>
-                  <a:srgbClr val="FFFFFF"/>
-                </a:solidFill>
-              </a:rPr>
-              <a:t>- If the One-Day and Two-Day shipping delays associated with warehouse 'B' are the result of order volume, staffing, or warehouse operations efficiency, then these potential bottlenecks should be rectified prior to moving extra inventory into warehouse 'B'.</a:t>
+              <a:t>- Check the amount of time each warehouse requires to ship an order.</a:t>
+            </a:r>
+          </a:p>
+          <a:p>
+            <a:pPr algn="l"/>
+            <a:r>
+              <a:rPr sz="2200">
+                <a:solidFill>
+                  <a:srgbClr val="FFFFFF"/>
+                </a:solidFill>
+              </a:rPr>
+              <a:t>- Look for shipping delays from each warehouse.</a:t>
+            </a:r>
+          </a:p>
+          <a:p>
+            <a:pPr algn="l"/>
+            <a:r>
+              <a:rPr sz="2200">
+                <a:solidFill>
+                  <a:srgbClr val="FFFFFF"/>
+                </a:solidFill>
+              </a:rPr>
+              <a:t>- Determine if shipping delays are incidental or a systemic issue.</a:t>
             </a:r>
           </a:p>
         </p:txBody>
       </p:sp>
       <p:pic>
         <p:nvPicPr>
-          <p:cNvPr id="7" name="Picture 6" descr="output_57_0.png"/>
+          <p:cNvPr id="7" name="Picture 6" descr="table_3.png"/>
           <p:cNvPicPr>
             <a:picLocks noChangeAspect="1"/>
           </p:cNvPicPr>
@@ -1459,7 +1402,31 @@
         <p:spPr>
           <a:xfrm>
             <a:off x="914400" y="914400"/>
-            <a:ext cx="10881360" cy="3520440"/>
+            <a:ext cx="6199632" cy="3561588"/>
+          </a:xfrm>
+          <a:prstGeom prst="rect">
+            <a:avLst/>
+          </a:prstGeom>
+        </p:spPr>
+      </p:pic>
+      <p:pic>
+        <p:nvPicPr>
+          <p:cNvPr id="8" name="Picture 7" descr="output_55_0.png"/>
+          <p:cNvPicPr>
+            <a:picLocks noChangeAspect="1"/>
+          </p:cNvPicPr>
+          <p:nvPr/>
+        </p:nvPicPr>
+        <p:blipFill>
+          <a:blip r:embed="rId3"/>
+          <a:stretch>
+            <a:fillRect/>
+          </a:stretch>
+        </p:blipFill>
+        <p:spPr>
+          <a:xfrm>
+            <a:off x="1371600" y="1371600"/>
+            <a:ext cx="10881360" cy="5394960"/>
           </a:xfrm>
           <a:prstGeom prst="rect">
             <a:avLst/>
@@ -1607,7 +1574,7 @@
                   <a:srgbClr val="FFFFFF"/>
                 </a:solidFill>
               </a:rPr>
-              <a:t>Next Steps:</a:t>
+              <a:t>Warehouse Shipping Efficiency (cont'd)</a:t>
             </a:r>
           </a:p>
         </p:txBody>
@@ -1641,7 +1608,7 @@
                   <a:srgbClr val="FFFFFF"/>
                 </a:solidFill>
               </a:rPr>
-              <a:t>Compare the actual volumes of Warehouse B and Warehouse C against the estimated model</a:t>
+              <a:t>After splitting the shipping delays into occurrences by location, normalized to maximum orders per bin:</a:t>
             </a:r>
           </a:p>
         </p:txBody>
@@ -1675,33 +1642,57 @@
                   <a:srgbClr val="FFFFFF"/>
                 </a:solidFill>
               </a:rPr>
-              <a:t>- It is extremely important to remember that the amount of space that any given portion of inventory shall occupy has been estimated here without the spacial burden of the items' packaging.</a:t>
-            </a:r>
-          </a:p>
-          <a:p>
-            <a:pPr algn="l"/>
-            <a:r>
-              <a:rPr sz="2200">
-                <a:solidFill>
-                  <a:srgbClr val="FFFFFF"/>
-                </a:solidFill>
-              </a:rPr>
-              <a:t>- It would be unsurprising to discover that the smaller scale models of current Warehouse C have proportionally more packaging than the somewhat larger models currently occupying Warehouse B.</a:t>
-            </a:r>
-          </a:p>
-          <a:p>
-            <a:pPr algn="l"/>
-            <a:r>
-              <a:rPr sz="2200">
-                <a:solidFill>
-                  <a:srgbClr val="FFFFFF"/>
-                </a:solidFill>
-              </a:rPr>
-              <a:t>- Both Warehouse B and Warehouse C will, in reality, be much larger than the generated volumes which were used to compare warehouse capacities.  Comparing the ratio of (Actual:Estimated) warehouse volume for each warehouse could possibly be used in lieu of ascertaining complete product packaging size information.</a:t>
-            </a:r>
-          </a:p>
-        </p:txBody>
-      </p:sp>
+              <a:t>- Warehouse 'B' has proportionally more One-Day shipping delays than warehouse 'C'.</a:t>
+            </a:r>
+          </a:p>
+          <a:p>
+            <a:pPr algn="l"/>
+            <a:r>
+              <a:rPr sz="2200">
+                <a:solidFill>
+                  <a:srgbClr val="FFFFFF"/>
+                </a:solidFill>
+              </a:rPr>
+              <a:t>- If warehouse 'C' were to be moved into warehouse 'B' then warehouse 'B' must be able to accommodate the extra orders each day.</a:t>
+            </a:r>
+          </a:p>
+          <a:p>
+            <a:pPr algn="l"/>
+            <a:r>
+              <a:rPr sz="2200">
+                <a:solidFill>
+                  <a:srgbClr val="FFFFFF"/>
+                </a:solidFill>
+              </a:rPr>
+              <a:t>- If the One-Day and Two-Day shipping delays associated with warehouse 'B' are the result of order volume, staffing, or warehouse operations efficiency, then these potential bottlenecks should be rectified prior to moving extra inventory into warehouse 'B'.</a:t>
+            </a:r>
+          </a:p>
+        </p:txBody>
+      </p:sp>
+      <p:pic>
+        <p:nvPicPr>
+          <p:cNvPr id="7" name="Picture 6" descr="output_58_0.png"/>
+          <p:cNvPicPr>
+            <a:picLocks noChangeAspect="1"/>
+          </p:cNvPicPr>
+          <p:nvPr/>
+        </p:nvPicPr>
+        <p:blipFill>
+          <a:blip r:embed="rId2"/>
+          <a:stretch>
+            <a:fillRect/>
+          </a:stretch>
+        </p:blipFill>
+        <p:spPr>
+          <a:xfrm>
+            <a:off x="914400" y="914400"/>
+            <a:ext cx="10881360" cy="3520440"/>
+          </a:xfrm>
+          <a:prstGeom prst="rect">
+            <a:avLst/>
+          </a:prstGeom>
+        </p:spPr>
+      </p:pic>
     </p:spTree>
   </p:cSld>
   <p:clrMapOvr>
@@ -1877,7 +1868,7 @@
                   <a:srgbClr val="FFFFFF"/>
                 </a:solidFill>
               </a:rPr>
-              <a:t>Look into the reasons why some items have incredibly low inventory stock</a:t>
+              <a:t>Compare the actual volumes of Warehouse B and Warehouse C against the estimated model</a:t>
             </a:r>
           </a:p>
         </p:txBody>
@@ -1911,29 +1902,29 @@
                   <a:srgbClr val="FFFFFF"/>
                 </a:solidFill>
               </a:rPr>
-              <a:t>- Are any of these items no longer available or difficult to acquire from the manufacturer?</a:t>
-            </a:r>
-          </a:p>
-          <a:p>
-            <a:pPr algn="l"/>
-            <a:r>
-              <a:rPr sz="2200">
-                <a:solidFill>
-                  <a:srgbClr val="FFFFFF"/>
-                </a:solidFill>
-              </a:rPr>
-              <a:t>- If so, consider dropping those products from the Mint Classics products catalogue.</a:t>
-            </a:r>
-          </a:p>
-          <a:p>
-            <a:pPr algn="l"/>
-            <a:r>
-              <a:rPr sz="2200">
-                <a:solidFill>
-                  <a:srgbClr val="FFFFFF"/>
-                </a:solidFill>
-              </a:rPr>
-              <a:t>- This method could be useful in warehouse reorganization more storage volume might be achieved from the same square footage with less individual product codes to keep organized and accessible.</a:t>
+              <a:t>- It is extremely important to remember that the amount of space that any given portion of inventory shall occupy has been estimated here without the spacial burden of the items' packaging.</a:t>
+            </a:r>
+          </a:p>
+          <a:p>
+            <a:pPr algn="l"/>
+            <a:r>
+              <a:rPr sz="2200">
+                <a:solidFill>
+                  <a:srgbClr val="FFFFFF"/>
+                </a:solidFill>
+              </a:rPr>
+              <a:t>- It would be unsurprising to discover that the smaller scale models of current Warehouse C have proportionally more packaging than the somewhat larger models currently occupying Warehouse B.</a:t>
+            </a:r>
+          </a:p>
+          <a:p>
+            <a:pPr algn="l"/>
+            <a:r>
+              <a:rPr sz="2200">
+                <a:solidFill>
+                  <a:srgbClr val="FFFFFF"/>
+                </a:solidFill>
+              </a:rPr>
+              <a:t>- Both Warehouse B and Warehouse C will, in reality, be much larger than the generated volumes which were used to compare warehouse capacities.  Comparing the ratio of (Actual:Estimated) warehouse volume for each warehouse could possibly be used in lieu of ascertaining complete product packaging size information.</a:t>
             </a:r>
           </a:p>
         </p:txBody>
@@ -2113,7 +2104,7 @@
                   <a:srgbClr val="FFFFFF"/>
                 </a:solidFill>
               </a:rPr>
-              <a:t>Consider the ability to handle the logistics of increased shipping from Warehouse B</a:t>
+              <a:t>Look into the reasons why some items have incredibly low inventory stock</a:t>
             </a:r>
           </a:p>
         </p:txBody>
@@ -2147,40 +2138,29 @@
                   <a:srgbClr val="FFFFFF"/>
                 </a:solidFill>
               </a:rPr>
-              <a:t>- At the outset of this analysis, Mint Classics expressed an interest in being able to ship products within 24 hours of receiving a purchase order.</a:t>
-            </a:r>
-          </a:p>
-          <a:p>
-            <a:pPr algn="l"/>
-            <a:r>
-              <a:rPr sz="2200">
-                <a:solidFill>
-                  <a:srgbClr val="FFFFFF"/>
-                </a:solidFill>
-              </a:rPr>
-              <a:t>- The warehouse to which the inventory of the proposed closure would be moved has a higher proportion of 2-3 day delays than the other warehouses.</a:t>
-            </a:r>
-          </a:p>
-          <a:p>
-            <a:pPr algn="l"/>
-            <a:r>
-              <a:rPr sz="2200">
-                <a:solidFill>
-                  <a:srgbClr val="FFFFFF"/>
-                </a:solidFill>
-              </a:rPr>
-              <a:t>- Ensure that warehouse staffing and logistics in Warehouse B will be capable of accommodating the estimated 100 extra line items of orders per day after amalgamation.</a:t>
-            </a:r>
-          </a:p>
-          <a:p>
-            <a:pPr algn="l"/>
-            <a:r>
-              <a:rPr sz="2200">
-                <a:solidFill>
-                  <a:srgbClr val="FFFFFF"/>
-                </a:solidFill>
-              </a:rPr>
-              <a:t>- Condense the existing inventory in Warehouse B creating a completely separate and empty space for the inventory of Warehouse C prior to shutting down Warehouse.</a:t>
+              <a:t>- Are any of these items no longer available or difficult to acquire from the manufacturer?</a:t>
+            </a:r>
+          </a:p>
+          <a:p>
+            <a:pPr algn="l"/>
+            <a:r>
+              <a:rPr sz="2200">
+                <a:solidFill>
+                  <a:srgbClr val="FFFFFF"/>
+                </a:solidFill>
+              </a:rPr>
+              <a:t>- If so, consider dropping those products from the Mint Classics products catalogue.</a:t>
+            </a:r>
+          </a:p>
+          <a:p>
+            <a:pPr algn="l"/>
+            <a:r>
+              <a:rPr sz="2200">
+                <a:solidFill>
+                  <a:srgbClr val="FFFFFF"/>
+                </a:solidFill>
+              </a:rPr>
+              <a:t>- This method could be useful in warehouse reorganization more storage volume might be achieved from the same square footage with less individual product codes to keep organized and accessible.</a:t>
             </a:r>
           </a:p>
         </p:txBody>
@@ -2326,7 +2306,97 @@
                   <a:srgbClr val="FFFFFF"/>
                 </a:solidFill>
               </a:rPr>
-              <a:t>Please feel free to come back with any other more specific questions regarding any aspect of this ongoing project.</a:t>
+              <a:t>Next Steps:</a:t>
+            </a:r>
+          </a:p>
+        </p:txBody>
+      </p:sp>
+      <p:sp>
+        <p:nvSpPr>
+          <p:cNvPr id="5" name="TextBox 4"/>
+          <p:cNvSpPr txBox="1"/>
+          <p:nvPr/>
+        </p:nvSpPr>
+        <p:spPr>
+          <a:xfrm>
+            <a:off x="640080" y="2286000"/>
+            <a:ext cx="8778240" cy="4114800"/>
+          </a:xfrm>
+          <a:prstGeom prst="rect">
+            <a:avLst/>
+          </a:prstGeom>
+          <a:noFill/>
+        </p:spPr>
+        <p:txBody>
+          <a:bodyPr wrap="square">
+            <a:spAutoFit/>
+          </a:bodyPr>
+          <a:lstStyle/>
+          <a:p>
+            <a:pPr algn="l"/>
+            <a:r>
+              <a:rPr sz="2200">
+                <a:solidFill>
+                  <a:srgbClr val="FFFFFF"/>
+                </a:solidFill>
+              </a:rPr>
+              <a:t>Consider the ability to handle the logistics of increased shipping from Warehouse B</a:t>
+            </a:r>
+          </a:p>
+        </p:txBody>
+      </p:sp>
+      <p:sp>
+        <p:nvSpPr>
+          <p:cNvPr id="6" name="TextBox 5"/>
+          <p:cNvSpPr txBox="1"/>
+          <p:nvPr/>
+        </p:nvSpPr>
+        <p:spPr>
+          <a:xfrm>
+            <a:off x="640080" y="2286000"/>
+            <a:ext cx="8778240" cy="4114800"/>
+          </a:xfrm>
+          <a:prstGeom prst="rect">
+            <a:avLst/>
+          </a:prstGeom>
+          <a:noFill/>
+        </p:spPr>
+        <p:txBody>
+          <a:bodyPr wrap="square">
+            <a:spAutoFit/>
+          </a:bodyPr>
+          <a:lstStyle/>
+          <a:p>
+            <a:pPr algn="l"/>
+            <a:r>
+              <a:rPr sz="2200">
+                <a:solidFill>
+                  <a:srgbClr val="FFFFFF"/>
+                </a:solidFill>
+              </a:rPr>
+              <a:t>- At the outset of this analysis, Mint Classics expressed an interest in being able to ship products within 24 hours of receiving a purchase order.</a:t>
+            </a:r>
+          </a:p>
+          <a:p>
+            <a:pPr algn="l"/>
+            <a:r>
+              <a:rPr sz="2200">
+                <a:solidFill>
+                  <a:srgbClr val="FFFFFF"/>
+                </a:solidFill>
+              </a:rPr>
+              <a:t>- The warehouse to which the inventory of the proposed closure would be moved has a higher proportion of 2-3 day delays than the other warehouses.</a:t>
+            </a:r>
+          </a:p>
+          <a:p>
+            <a:pPr algn="l"/>
+            <a:r>
+              <a:rPr sz="2200">
+                <a:solidFill>
+                  <a:srgbClr val="FFFFFF"/>
+                </a:solidFill>
+              </a:rPr>
+              <a:t>- Condense the existing inventory in Warehouse B creating a completely separate and empty space for the inventory of Warehouse C prior to shutting down Warehouse.</a:t>
             </a:r>
           </a:p>
         </p:txBody>
@@ -2357,6 +2427,152 @@
         </p:nvSpPr>
         <p:spPr>
           <a:xfrm>
+            <a:off x="640080" y="685800"/>
+            <a:ext cx="8778240" cy="1371600"/>
+          </a:xfrm>
+          <a:prstGeom prst="rect">
+            <a:avLst/>
+          </a:prstGeom>
+          <a:solidFill>
+            <a:srgbClr val="9B9B9B"/>
+          </a:solidFill>
+          <a:ln w="31750">
+            <a:solidFill>
+              <a:srgbClr val="9B9B9B">
+                <a:lumMod val="85000"/>
+              </a:srgbClr>
+            </a:solidFill>
+          </a:ln>
+        </p:spPr>
+        <p:style>
+          <a:lnRef idx="1">
+            <a:schemeClr val="accent1"/>
+          </a:lnRef>
+          <a:fillRef idx="3">
+            <a:schemeClr val="accent1"/>
+          </a:fillRef>
+          <a:effectRef idx="2">
+            <a:schemeClr val="accent1"/>
+          </a:effectRef>
+          <a:fontRef idx="minor">
+            <a:schemeClr val="lt1"/>
+          </a:fontRef>
+        </p:style>
+        <p:txBody>
+          <a:bodyPr rtlCol="0" anchor="ctr"/>
+          <a:lstStyle/>
+          <a:p>
+            <a:pPr algn="ctr"/>
+          </a:p>
+        </p:txBody>
+      </p:sp>
+      <p:sp>
+        <p:nvSpPr>
+          <p:cNvPr id="3" name="Rectangle 2"/>
+          <p:cNvSpPr/>
+          <p:nvPr/>
+        </p:nvSpPr>
+        <p:spPr>
+          <a:xfrm>
+            <a:off x="640080" y="2286000"/>
+            <a:ext cx="8778240" cy="4114800"/>
+          </a:xfrm>
+          <a:prstGeom prst="rect">
+            <a:avLst/>
+          </a:prstGeom>
+          <a:solidFill>
+            <a:srgbClr val="9B9B9B"/>
+          </a:solidFill>
+          <a:ln w="31750">
+            <a:solidFill>
+              <a:srgbClr val="9B9B9B">
+                <a:lumMod val="85000"/>
+              </a:srgbClr>
+            </a:solidFill>
+          </a:ln>
+        </p:spPr>
+        <p:style>
+          <a:lnRef idx="1">
+            <a:schemeClr val="accent1"/>
+          </a:lnRef>
+          <a:fillRef idx="3">
+            <a:schemeClr val="accent1"/>
+          </a:fillRef>
+          <a:effectRef idx="2">
+            <a:schemeClr val="accent1"/>
+          </a:effectRef>
+          <a:fontRef idx="minor">
+            <a:schemeClr val="lt1"/>
+          </a:fontRef>
+        </p:style>
+        <p:txBody>
+          <a:bodyPr rtlCol="0" anchor="ctr"/>
+          <a:lstStyle/>
+          <a:p>
+            <a:pPr algn="ctr"/>
+          </a:p>
+        </p:txBody>
+      </p:sp>
+      <p:sp>
+        <p:nvSpPr>
+          <p:cNvPr id="4" name="TextBox 3"/>
+          <p:cNvSpPr txBox="1"/>
+          <p:nvPr/>
+        </p:nvSpPr>
+        <p:spPr>
+          <a:xfrm>
+            <a:off x="640080" y="685800"/>
+            <a:ext cx="8778240" cy="1371600"/>
+          </a:xfrm>
+          <a:prstGeom prst="rect">
+            <a:avLst/>
+          </a:prstGeom>
+          <a:noFill/>
+        </p:spPr>
+        <p:txBody>
+          <a:bodyPr wrap="square">
+            <a:spAutoFit/>
+          </a:bodyPr>
+          <a:lstStyle/>
+          <a:p>
+            <a:pPr algn="ctr"/>
+            <a:r>
+              <a:rPr sz="4200">
+                <a:solidFill>
+                  <a:srgbClr val="FFFFFF"/>
+                </a:solidFill>
+              </a:rPr>
+              <a:t>Please feel free to come back with any other more specific questions regarding any aspect of this ongoing project.</a:t>
+            </a:r>
+          </a:p>
+        </p:txBody>
+      </p:sp>
+    </p:spTree>
+  </p:cSld>
+  <p:clrMapOvr>
+    <a:masterClrMapping/>
+  </p:clrMapOvr>
+</p:sld>
+</file>
+
+<file path=ppt/slides/slide17.xml><?xml version="1.0" encoding="utf-8"?>
+<p:sld xmlns:a="http://schemas.openxmlformats.org/drawingml/2006/main" xmlns:p="http://schemas.openxmlformats.org/presentationml/2006/main" xmlns:r="http://schemas.openxmlformats.org/officeDocument/2006/relationships">
+  <p:cSld>
+    <p:spTree>
+      <p:nvGrpSpPr>
+        <p:cNvPr id="1" name=""/>
+        <p:cNvGrpSpPr/>
+        <p:nvPr/>
+      </p:nvGrpSpPr>
+      <p:grpSpPr/>
+      <p:sp>
+        <p:nvSpPr>
+          <p:cNvPr id="2" name="Rectangle 1"/>
+          <p:cNvSpPr/>
+          <p:nvPr/>
+        </p:nvSpPr>
+        <p:spPr>
+          <a:xfrm>
             <a:off x="640080" y="822960"/>
             <a:ext cx="8778240" cy="5029200"/>
           </a:xfrm>
@@ -2627,7 +2843,7 @@
                   <a:srgbClr val="FFFFFF"/>
                 </a:solidFill>
               </a:rPr>
-              <a:t>- The cost of the stock in Warehouse A is comparatively higher than the cost of the stock stored in any of the other warehouses as demonstrated by the 'Investment Value' being 6% higher than the 'Stock Quantity'</a:t>
+              <a:t>- The cost of the stock in Warehouse B is comparatively higher than the cost of the stock stored in any of the other warehouses as demonstrated by the 'Investment Value' being 7% higher than the 'Stock Quantity'</a:t>
             </a:r>
           </a:p>
         </p:txBody>
@@ -2649,7 +2865,7 @@
         <p:spPr>
           <a:xfrm>
             <a:off x="914400" y="914400"/>
-            <a:ext cx="14648688" cy="5952744"/>
+            <a:ext cx="14657832" cy="5916168"/>
           </a:xfrm>
           <a:prstGeom prst="rect">
             <a:avLst/>
@@ -3305,36 +3521,59 @@
                   <a:srgbClr val="FFFFFF"/>
                 </a:solidFill>
               </a:rPr>
-              <a:t>- All warehouses are selling inventory with reasonable distributions.</a:t>
-            </a:r>
-          </a:p>
-          <a:p>
-            <a:pPr algn="l"/>
-            <a:r>
-              <a:rPr sz="2200">
-                <a:solidFill>
-                  <a:srgbClr val="FFFFFF"/>
-                </a:solidFill>
-              </a:rPr>
-              <a:t>- All warehouses contain some products which appear to contain insufficient stock levels based on previous sales.</a:t>
-            </a:r>
-          </a:p>
-          <a:p>
-            <a:pPr algn="l"/>
-            <a:r>
-              <a:rPr sz="2200">
-                <a:solidFill>
-                  <a:srgbClr val="FFFFFF"/>
-                </a:solidFill>
-              </a:rPr>
-              <a:t>- Depending on the reasons behind the low inventory of certain products it may be advisable to discontinue those particular products.</a:t>
+              <a:t>Notice that there have been ZERO sales for product S18_3233</a:t>
+            </a:r>
+          </a:p>
+        </p:txBody>
+      </p:sp>
+      <p:sp>
+        <p:nvSpPr>
+          <p:cNvPr id="6" name="TextBox 5"/>
+          <p:cNvSpPr txBox="1"/>
+          <p:nvPr/>
+        </p:nvSpPr>
+        <p:spPr>
+          <a:xfrm>
+            <a:off x="640080" y="2286000"/>
+            <a:ext cx="8778240" cy="4114800"/>
+          </a:xfrm>
+          <a:prstGeom prst="rect">
+            <a:avLst/>
+          </a:prstGeom>
+          <a:noFill/>
+        </p:spPr>
+        <p:txBody>
+          <a:bodyPr wrap="square">
+            <a:spAutoFit/>
+          </a:bodyPr>
+          <a:lstStyle/>
+          <a:p>
+            <a:pPr algn="l"/>
+            <a:r>
+              <a:rPr sz="2200">
+                <a:solidFill>
+                  <a:srgbClr val="FFFFFF"/>
+                </a:solidFill>
+              </a:rPr>
+              <a:t>- Product S18_3233 is a 1885 Toyota Supra by Highway 66 Mini Classics.</a:t>
+            </a:r>
+          </a:p>
+          <a:p>
+            <a:pPr algn="l"/>
+            <a:r>
+              <a:rPr sz="2200">
+                <a:solidFill>
+                  <a:srgbClr val="FFFFFF"/>
+                </a:solidFill>
+              </a:rPr>
+              <a:t>- This SKU should definately be considered for discontinuation.</a:t>
             </a:r>
           </a:p>
         </p:txBody>
       </p:sp>
       <p:pic>
         <p:nvPicPr>
-          <p:cNvPr id="6" name="Picture 5" descr="output_29_0.png"/>
+          <p:cNvPr id="7" name="Picture 6" descr="table_0.png"/>
           <p:cNvPicPr>
             <a:picLocks noChangeAspect="1"/>
           </p:cNvPicPr>
@@ -3349,7 +3588,7 @@
         <p:spPr>
           <a:xfrm>
             <a:off x="914400" y="914400"/>
-            <a:ext cx="10954512" cy="3776472"/>
+            <a:ext cx="7022592" cy="3561588"/>
           </a:xfrm>
           <a:prstGeom prst="rect">
             <a:avLst/>
@@ -3497,7 +3736,7 @@
                   <a:srgbClr val="FFFFFF"/>
                 </a:solidFill>
               </a:rPr>
-              <a:t>Check Low-Stock by Manufacturer</a:t>
+              <a:t>Sort Products by Warehouse (Cont'd)</a:t>
             </a:r>
           </a:p>
         </p:txBody>
@@ -3531,36 +3770,36 @@
                   <a:srgbClr val="FFFFFF"/>
                 </a:solidFill>
               </a:rPr>
-              <a:t>- Check for low stock by the current investment in inventory by product code.</a:t>
-            </a:r>
-          </a:p>
-          <a:p>
-            <a:pPr algn="l"/>
-            <a:r>
-              <a:rPr sz="2200">
-                <a:solidFill>
-                  <a:srgbClr val="FFFFFF"/>
-                </a:solidFill>
-              </a:rPr>
-              <a:t>- Inspect whether there is any correlation between low-stock items and any particular manufacturer.</a:t>
-            </a:r>
-          </a:p>
-          <a:p>
-            <a:pPr algn="l"/>
-            <a:r>
-              <a:rPr sz="2200">
-                <a:solidFill>
-                  <a:srgbClr val="FFFFFF"/>
-                </a:solidFill>
-              </a:rPr>
-              <a:t>- Seven out of 13 product vendors are represented in the Top10 lowest inventory query.</a:t>
+              <a:t>- All warehouses are selling inventory with reasonable distributions.</a:t>
+            </a:r>
+          </a:p>
+          <a:p>
+            <a:pPr algn="l"/>
+            <a:r>
+              <a:rPr sz="2200">
+                <a:solidFill>
+                  <a:srgbClr val="FFFFFF"/>
+                </a:solidFill>
+              </a:rPr>
+              <a:t>- All warehouses contain some products which appear to contain insufficient stock levels based on previous sales.</a:t>
+            </a:r>
+          </a:p>
+          <a:p>
+            <a:pPr algn="l"/>
+            <a:r>
+              <a:rPr sz="2200">
+                <a:solidFill>
+                  <a:srgbClr val="FFFFFF"/>
+                </a:solidFill>
+              </a:rPr>
+              <a:t>- Depending on the reasons behind the low inventory of certain products it may be advisable to discontinue those particular products.</a:t>
             </a:r>
           </a:p>
         </p:txBody>
       </p:sp>
       <p:pic>
         <p:nvPicPr>
-          <p:cNvPr id="6" name="Picture 5" descr="table_0.png"/>
+          <p:cNvPr id="6" name="Picture 5" descr="output_30_0.png"/>
           <p:cNvPicPr>
             <a:picLocks noChangeAspect="1"/>
           </p:cNvPicPr>
@@ -3575,7 +3814,7 @@
         <p:spPr>
           <a:xfrm>
             <a:off x="914400" y="914400"/>
-            <a:ext cx="6021324" cy="3561588"/>
+            <a:ext cx="10954512" cy="3776472"/>
           </a:xfrm>
           <a:prstGeom prst="rect">
             <a:avLst/>
@@ -3723,7 +3962,7 @@
                   <a:srgbClr val="FFFFFF"/>
                 </a:solidFill>
               </a:rPr>
-              <a:t>Reinspect the Overhead Graphs Sorted by Product Vendor</a:t>
+              <a:t>Check Low-Stock by Manufacturer</a:t>
             </a:r>
           </a:p>
         </p:txBody>
@@ -3757,36 +3996,36 @@
                   <a:srgbClr val="FFFFFF"/>
                 </a:solidFill>
               </a:rPr>
-              <a:t>- Clearly now, issues regarding low-stock inventory are with respect to individual products and not the fault of any single supplier.</a:t>
-            </a:r>
-          </a:p>
-          <a:p>
-            <a:pPr algn="l"/>
-            <a:r>
-              <a:rPr sz="2200">
-                <a:solidFill>
-                  <a:srgbClr val="FFFFFF"/>
-                </a:solidFill>
-              </a:rPr>
-              <a:t>- Low stock levels are not directly correlated to high sales volumes in most cases.</a:t>
-            </a:r>
-          </a:p>
-          <a:p>
-            <a:pPr algn="l"/>
-            <a:r>
-              <a:rPr sz="2200">
-                <a:solidFill>
-                  <a:srgbClr val="FFFFFF"/>
-                </a:solidFill>
-              </a:rPr>
-              <a:t>- The dataset lacks the necessary product supply information required to investigate any further at this time.</a:t>
+              <a:t>- Check for low stock by the current investment in inventory by product code.</a:t>
+            </a:r>
+          </a:p>
+          <a:p>
+            <a:pPr algn="l"/>
+            <a:r>
+              <a:rPr sz="2200">
+                <a:solidFill>
+                  <a:srgbClr val="FFFFFF"/>
+                </a:solidFill>
+              </a:rPr>
+              <a:t>- Inspect whether there is any correlation between low-stock items and any particular manufacturer.</a:t>
+            </a:r>
+          </a:p>
+          <a:p>
+            <a:pPr algn="l"/>
+            <a:r>
+              <a:rPr sz="2200">
+                <a:solidFill>
+                  <a:srgbClr val="FFFFFF"/>
+                </a:solidFill>
+              </a:rPr>
+              <a:t>- Seven out of 13 product vendors are represented in the Top10 lowest inventory query.</a:t>
             </a:r>
           </a:p>
         </p:txBody>
       </p:sp>
       <p:pic>
         <p:nvPicPr>
-          <p:cNvPr id="6" name="Picture 5" descr="output_36_0.png"/>
+          <p:cNvPr id="6" name="Picture 5" descr="table_1.png"/>
           <p:cNvPicPr>
             <a:picLocks noChangeAspect="1"/>
           </p:cNvPicPr>
@@ -3801,7 +4040,7 @@
         <p:spPr>
           <a:xfrm>
             <a:off x="914400" y="914400"/>
-            <a:ext cx="11000232" cy="5641848"/>
+            <a:ext cx="6021324" cy="3561588"/>
           </a:xfrm>
           <a:prstGeom prst="rect">
             <a:avLst/>
@@ -3949,7 +4188,7 @@
                   <a:srgbClr val="FFFFFF"/>
                 </a:solidFill>
               </a:rPr>
-              <a:t>Check Warehouse Volumes</a:t>
+              <a:t>Reinspect the Overhead Graphs Sorted by Product Vendor</a:t>
             </a:r>
           </a:p>
         </p:txBody>
@@ -3983,47 +4222,36 @@
                   <a:srgbClr val="FFFFFF"/>
                 </a:solidFill>
               </a:rPr>
-              <a:t>- Actual packaging volume information was not available.</a:t>
-            </a:r>
-          </a:p>
-          <a:p>
-            <a:pPr algn="l"/>
-            <a:r>
-              <a:rPr sz="2200">
-                <a:solidFill>
-                  <a:srgbClr val="FFFFFF"/>
-                </a:solidFill>
-              </a:rPr>
-              <a:t>- A list of the approximate product volumes has been generated based on product names and scale for the purpose of analysis.</a:t>
-            </a:r>
-          </a:p>
-          <a:p>
-            <a:pPr algn="l"/>
-            <a:r>
-              <a:rPr sz="2200">
-                <a:solidFill>
-                  <a:srgbClr val="FFFFFF"/>
-                </a:solidFill>
-              </a:rPr>
-              <a:t>- The largest warehouse, Warehouse B, shows enough space remaining to hold the stock from either Warehouse C or Warehouse D.</a:t>
-            </a:r>
-          </a:p>
-          <a:p>
-            <a:pPr algn="l"/>
-            <a:r>
-              <a:rPr sz="2200">
-                <a:solidFill>
-                  <a:srgbClr val="FFFFFF"/>
-                </a:solidFill>
-              </a:rPr>
-              <a:t>- Considering that Warehouse C is half-empty, this may a good candidate for closure.</a:t>
+              <a:t>- Clearly now, issues regarding low-stock inventory are with respect to individual products and not the fault of any single supplier.</a:t>
+            </a:r>
+          </a:p>
+          <a:p>
+            <a:pPr algn="l"/>
+            <a:r>
+              <a:rPr sz="2200">
+                <a:solidFill>
+                  <a:srgbClr val="FFFFFF"/>
+                </a:solidFill>
+              </a:rPr>
+              <a:t>- Low stock levels are not directly correlated to high sales volumes in most cases.</a:t>
+            </a:r>
+          </a:p>
+          <a:p>
+            <a:pPr algn="l"/>
+            <a:r>
+              <a:rPr sz="2200">
+                <a:solidFill>
+                  <a:srgbClr val="FFFFFF"/>
+                </a:solidFill>
+              </a:rPr>
+              <a:t>- The dataset lacks the necessary product supply information required to investigate any further at this time.</a:t>
             </a:r>
           </a:p>
         </p:txBody>
       </p:sp>
       <p:pic>
         <p:nvPicPr>
-          <p:cNvPr id="6" name="Picture 5" descr="output_43_0.png"/>
+          <p:cNvPr id="6" name="Picture 5" descr="output_37_0.png"/>
           <p:cNvPicPr>
             <a:picLocks noChangeAspect="1"/>
           </p:cNvPicPr>
@@ -4038,7 +4266,7 @@
         <p:spPr>
           <a:xfrm>
             <a:off x="914400" y="914400"/>
-            <a:ext cx="9052560" cy="4480560"/>
+            <a:ext cx="10954512" cy="5641848"/>
           </a:xfrm>
           <a:prstGeom prst="rect">
             <a:avLst/>
@@ -4186,7 +4414,7 @@
                   <a:srgbClr val="FFFFFF"/>
                 </a:solidFill>
               </a:rPr>
-              <a:t>Check the Warehouse Contents</a:t>
+              <a:t>Check Warehouse Volumes</a:t>
             </a:r>
           </a:p>
         </p:txBody>
@@ -4220,36 +4448,47 @@
                   <a:srgbClr val="FFFFFF"/>
                 </a:solidFill>
               </a:rPr>
-              <a:t>- It can be seen that the large warehouse "B" contains only 'Classic Cars'.</a:t>
-            </a:r>
-          </a:p>
-          <a:p>
-            <a:pPr algn="l"/>
-            <a:r>
-              <a:rPr sz="2200">
-                <a:solidFill>
-                  <a:srgbClr val="FFFFFF"/>
-                </a:solidFill>
-              </a:rPr>
-              <a:t>- The warehouse which is a candidate for closure, "C", contains only 'Vintage Cars'.</a:t>
-            </a:r>
-          </a:p>
-          <a:p>
-            <a:pPr algn="l"/>
-            <a:r>
-              <a:rPr sz="2200">
-                <a:solidFill>
-                  <a:srgbClr val="FFFFFF"/>
-                </a:solidFill>
-              </a:rPr>
-              <a:t>- Merging the contents of warehouses B and C would allow for the full stock of 'Cars' to be housed in a single location.</a:t>
+              <a:t>- Actual packaging volume information was not available.</a:t>
+            </a:r>
+          </a:p>
+          <a:p>
+            <a:pPr algn="l"/>
+            <a:r>
+              <a:rPr sz="2200">
+                <a:solidFill>
+                  <a:srgbClr val="FFFFFF"/>
+                </a:solidFill>
+              </a:rPr>
+              <a:t>- A list of the approximate product volumes has been generated based on product names and scale for the purpose of analysis.</a:t>
+            </a:r>
+          </a:p>
+          <a:p>
+            <a:pPr algn="l"/>
+            <a:r>
+              <a:rPr sz="2200">
+                <a:solidFill>
+                  <a:srgbClr val="FFFFFF"/>
+                </a:solidFill>
+              </a:rPr>
+              <a:t>- The largest warehouse, Warehouse B, shows enough space remaining to hold the stock from either Warehouse C or Warehouse D.</a:t>
+            </a:r>
+          </a:p>
+          <a:p>
+            <a:pPr algn="l"/>
+            <a:r>
+              <a:rPr sz="2200">
+                <a:solidFill>
+                  <a:srgbClr val="FFFFFF"/>
+                </a:solidFill>
+              </a:rPr>
+              <a:t>- Considering that Warehouse C is half-empty, this may a good candidate for closure.</a:t>
             </a:r>
           </a:p>
         </p:txBody>
       </p:sp>
       <p:pic>
         <p:nvPicPr>
-          <p:cNvPr id="6" name="Picture 5" descr="table_1.png"/>
+          <p:cNvPr id="6" name="Picture 5" descr="output_44_0.png"/>
           <p:cNvPicPr>
             <a:picLocks noChangeAspect="1"/>
           </p:cNvPicPr>
@@ -4264,7 +4503,7 @@
         <p:spPr>
           <a:xfrm>
             <a:off x="914400" y="914400"/>
-            <a:ext cx="6752844" cy="3561588"/>
+            <a:ext cx="9052560" cy="4480560"/>
           </a:xfrm>
           <a:prstGeom prst="rect">
             <a:avLst/>

</xml_diff>